<commit_message>
docs: nombre completo del docente (Dr. Jack Harry Peralta Caceres) en informes, actas, decisiones y deck
</commit_message>
<xml_diff>
--- a/docs/informe/exposicion-gs08-2026-10-13.pptx
+++ b/docs/informe/exposicion-gs08-2026-10-13.pptx
@@ -4261,7 +4261,7 @@
                   <a:srgbClr val="1F4E79"/>
                 </a:solidFill>
               </a:rPr>
-              <a:t>Curso GS08 · Docente: Dr. Jack Peralta</a:t>
+              <a:t>Curso GS08 · Docente: Dr. Jack Harry Peralta Cáceres</a:t>
             </a:r>
           </a:p>
           <a:p>
@@ -4328,7 +4328,7 @@
           <a:lstStyle/>
           <a:p>
             <a:r>
-              <a:t>Sprint 0 → Sprint 4: entregado, bloqueado y retrospectiva</a:t>
+              <a:t>Calidad: 39 criterios y lo que apareció probando</a:t>
             </a:r>
           </a:p>
         </p:txBody>
@@ -4351,28 +4351,28 @@
             <a:pPr/>
             <a:r>
               <a:rPr sz="1500"/>
-              <a:t>Sprint 0 cerrado con evidencia: alcance, modelo de datos verificado, infraestructura probada, plan de pruebas y documentación completa.</a:t>
+              <a:t>22 criterios verificados con corrida real · 4 incumplidos por los dos 500 · 2 en arreglo · 6 pendientes de interfaz · 5 bloqueados con motivo.</a:t>
             </a:r>
           </a:p>
           <a:p>
             <a:pPr/>
             <a:r>
               <a:rPr sz="1500"/>
-              <a:t>Sprint 1 en curso (28 endpoints, 22 criterios verdes) y Sprint 3 adelantado: notas y boleta funcionando.</a:t>
+              <a:t>9 bugs documentados con pasos, esperado, obtenido y evidencia — y 4 bugs encontrados en el propio script de pruebas.</a:t>
             </a:r>
           </a:p>
           <a:p>
             <a:pPr/>
             <a:r>
               <a:rPr sz="1500"/>
-              <a:t>Bloqueado y dicho de frente: cluster de Kubernetes (A-02), repositorio público y CI, y el SPA (T2.4).</a:t>
+              <a:t>Hallazgos que valieron la pena: un verificador que fallaba en entorno limpio, criterios con datos inexistentes y un /metrics que devolvía el SPA.</a:t>
             </a:r>
           </a:p>
           <a:p>
             <a:pPr/>
             <a:r>
-              <a:rPr sz="1500"/>
-              <a:t>Retrospectiva: probar temprano pagó; cada hallazgo terminó en una decisión o en una tarea con dueño.</a:t>
+              <a:rPr sz="1500" b="1"/>
+              <a:t>Regla de la casa: un bug no se cierra por decisión, se cierra con la corrida verde pegada.</a:t>
             </a:r>
           </a:p>
         </p:txBody>
@@ -4411,7 +4411,7 @@
           <a:lstStyle/>
           <a:p>
             <a:r>
-              <a:t>Migración del frontend: Vue 3 → React 19</a:t>
+              <a:t>Sprint 0 → Sprint 4: entregado, bloqueado y retrospectiva</a:t>
             </a:r>
           </a:p>
         </p:txBody>
@@ -4431,27 +4431,31 @@
           <a:bodyPr/>
           <a:lstStyle/>
           <a:p>
+            <a:pPr/>
             <a:r>
               <a:rPr sz="1500"/>
-              <a:t>Por qué: la rúbrica del trabajo colaborativo de Implementación de Soluciones para Plataformas Web pide React con Tailwind. Se migra el frontend para cumplirla.</a:t>
-            </a:r>
-          </a:p>
-          <a:p>
+              <a:t>Sprint 0 cerrado con evidencia: alcance, modelo de datos verificado, infraestructura probada, plan de pruebas y documentación completa.</a:t>
+            </a:r>
+          </a:p>
+          <a:p>
+            <a:pPr/>
             <a:r>
               <a:rPr sz="1500"/>
-              <a:t>Qué cambia: solo la capa de presentación. La SPA está desacoplada del API —todo pasa por /api/v1—, así que no se toca el backend, ni la base de datos, ni la infraestructura.</a:t>
-            </a:r>
-          </a:p>
-          <a:p>
+              <a:t>Sprint 1 en curso (28 endpoints, 22 criterios verdes) y Sprint 3 adelantado: notas y boleta funcionando.</a:t>
+            </a:r>
+          </a:p>
+          <a:p>
+            <a:pPr/>
             <a:r>
               <a:rPr sz="1500"/>
-              <a:t>Qué se gana: de 4 vistas al consumo de las 30 operaciones del contrato, con cursos, usuarios, notas y boleta, más búsqueda, filtros, paginación y pruebas.</a:t>
-            </a:r>
-          </a:p>
-          <a:p>
+              <a:t>Bloqueado y dicho de frente: cluster de Kubernetes (A-02), repositorio público y CI, y el SPA (T2.4).</a:t>
+            </a:r>
+          </a:p>
+          <a:p>
+            <a:pPr/>
             <a:r>
               <a:rPr sz="1500"/>
-              <a:t>Despliegue: mismo build estático servido por nginx, misma imagen y el mismo Coolify. El cambio no altera el entorno publicado: se vuelve a construir y listo.</a:t>
+              <a:t>Retrospectiva: probar temprano pagó; cada hallazgo terminó en una decisión o en una tarea con dueño.</a:t>
             </a:r>
           </a:p>
         </p:txBody>
@@ -4893,7 +4897,7 @@
           <a:lstStyle/>
           <a:p>
             <a:r>
-              <a:t>Contenedores y CI</a:t>
+              <a:t>Migración del frontend: Vue 3 → React 19</a:t>
             </a:r>
           </a:p>
         </p:txBody>
@@ -4913,31 +4917,27 @@
           <a:bodyPr/>
           <a:lstStyle/>
           <a:p>
-            <a:pPr/>
             <a:r>
               <a:rPr sz="1500"/>
-              <a:t>6 contenedores con un solo comando: web (nginx 8080), dos instancias del API, PostgreSQL, Prometheus y Grafana.</a:t>
-            </a:r>
-          </a:p>
-          <a:p>
-            <a:pPr/>
+              <a:t>Por qué: la rúbrica del trabajo colaborativo de Implementación de Soluciones para Plataformas Web pide React con Tailwind. Se migra el frontend para cumplirla.</a:t>
+            </a:r>
+          </a:p>
+          <a:p>
             <a:r>
               <a:rPr sz="1500"/>
-              <a:t>Balanceo real 1 a 1 entre las dos instancias; con una apagada, 6 peticiones siguen dando 200 con reintento (failover).</a:t>
-            </a:r>
-          </a:p>
-          <a:p>
-            <a:pPr/>
+              <a:t>Qué cambia: solo la capa de presentación. La SPA está desacoplada del API —todo pasa por /api/v1—, así que no se toca el backend, ni la base de datos, ni la infraestructura.</a:t>
+            </a:r>
+          </a:p>
+          <a:p>
             <a:r>
               <a:rPr sz="1500"/>
-              <a:t>CI en cada pull request: infra + backend (ruff y pytest, cobertura mínima 60 %) + frontend + imágenes con smoke y escaneo.</a:t>
-            </a:r>
-          </a:p>
-          <a:p>
-            <a:pPr/>
+              <a:t>Qué se gana: de 4 vistas al consumo de las 30 operaciones del contrato, con cursos, usuarios, notas y boleta, más búsqueda, filtros, paginación y pruebas.</a:t>
+            </a:r>
+          </a:p>
+          <a:p>
             <a:r>
               <a:rPr sz="1500"/>
-              <a:t>CD: publica en GHCR con SBOM y provenance; el despliegue a Kubernetes queda guardado tras DEPLOY_ENABLED=true.</a:t>
+              <a:t>Despliegue: mismo build estático servido por nginx, misma imagen y el mismo Coolify. El cambio no altera el entorno publicado: se vuelve a construir y listo.</a:t>
             </a:r>
           </a:p>
         </p:txBody>
@@ -4976,7 +4976,7 @@
           <a:lstStyle/>
           <a:p>
             <a:r>
-              <a:t>Kubernetes local y observabilidad</a:t>
+              <a:t>Contenedores y CI</a:t>
             </a:r>
           </a:p>
         </p:txBody>
@@ -4999,28 +4999,28 @@
             <a:pPr/>
             <a:r>
               <a:rPr sz="1500"/>
-              <a:t>11 objetos definidos y validados offline con kustomize: Namespace, ConfigMap, PVC, Job de migraciones, Deployments, Services e Ingress.</a:t>
+              <a:t>6 contenedores con un solo comando: web (nginx 8080), dos instancias del API, PostgreSQL, Prometheus y Grafana.</a:t>
             </a:r>
           </a:p>
           <a:p>
             <a:pPr/>
             <a:r>
               <a:rPr sz="1500"/>
-              <a:t>En el cluster el esquema lo aplica Alembic con el Job de migraciones, no los scripts de inicialización.</a:t>
+              <a:t>Balanceo real 1 a 1 entre las dos instancias; con una apagada, 6 peticiones siguen dando 200 con reintento (failover).</a:t>
             </a:r>
           </a:p>
           <a:p>
             <a:pPr/>
             <a:r>
               <a:rPr sz="1500"/>
-              <a:t>Observabilidad corriendo: 3 targets up y un dashboard API RED con 9 paneles con datos, provisionado desde el repositorio.</a:t>
+              <a:t>CI en cada pull request: infra + backend (ruff y pytest, cobertura mínima 60 %) + frontend + imágenes con smoke y escaneo.</a:t>
             </a:r>
           </a:p>
           <a:p>
             <a:pPr/>
             <a:r>
-              <a:rPr sz="1500" b="1"/>
-              <a:t>ESTADO REAL: el cluster NO está desplegado en esta máquina — minikube no está instalado y espera aprobación (A-02).</a:t>
+              <a:rPr sz="1500"/>
+              <a:t>CD: publica en GHCR con SBOM y provenance; el despliegue a Kubernetes queda guardado tras DEPLOY_ENABLED=true.</a:t>
             </a:r>
           </a:p>
         </p:txBody>
@@ -5059,7 +5059,7 @@
           <a:lstStyle/>
           <a:p>
             <a:r>
-              <a:t>Calidad: 39 criterios y lo que apareció probando</a:t>
+              <a:t>Kubernetes local y observabilidad</a:t>
             </a:r>
           </a:p>
         </p:txBody>
@@ -5082,28 +5082,28 @@
             <a:pPr/>
             <a:r>
               <a:rPr sz="1500"/>
-              <a:t>22 criterios verificados con corrida real · 4 incumplidos por los dos 500 · 2 en arreglo · 6 pendientes de interfaz · 5 bloqueados con motivo.</a:t>
+              <a:t>11 objetos definidos y validados offline con kustomize: Namespace, ConfigMap, PVC, Job de migraciones, Deployments, Services e Ingress.</a:t>
             </a:r>
           </a:p>
           <a:p>
             <a:pPr/>
             <a:r>
               <a:rPr sz="1500"/>
-              <a:t>9 bugs documentados con pasos, esperado, obtenido y evidencia — y 4 bugs encontrados en el propio script de pruebas.</a:t>
+              <a:t>En el cluster el esquema lo aplica Alembic con el Job de migraciones, no los scripts de inicialización.</a:t>
             </a:r>
           </a:p>
           <a:p>
             <a:pPr/>
             <a:r>
               <a:rPr sz="1500"/>
-              <a:t>Hallazgos que valieron la pena: un verificador que fallaba en entorno limpio, criterios con datos inexistentes y un /metrics que devolvía el SPA.</a:t>
+              <a:t>Observabilidad corriendo: 3 targets up y un dashboard API RED con 9 paneles con datos, provisionado desde el repositorio.</a:t>
             </a:r>
           </a:p>
           <a:p>
             <a:pPr/>
             <a:r>
               <a:rPr sz="1500" b="1"/>
-              <a:t>Regla de la casa: un bug no se cierra por decisión, se cierra con la corrida verde pegada.</a:t>
+              <a:t>ESTADO REAL: el cluster NO está desplegado en esta máquina — minikube no está instalado y espera aprobación (A-02).</a:t>
             </a:r>
           </a:p>
         </p:txBody>

</xml_diff>

<commit_message>
ci(cd): despliegue del VPS (Coolify) como job de entrega continua
El entorno real del proyecto es el VPS del grupo con Coolify, asi que el CD se
cierra desde GitHub Actions: el job desplegar_vps pide el despliegue por la API
de Coolify al terminar el CI en verde sobre main, espera el estado finished y
verifica produccion (health 200 y el bundle servido).

Queda apagado por la variable VPS_DEPLOY_ENABLED (mismo patron que los otros dos
despliegues del repo) hasta que el dueno configure el secret COOLIFY_TOKEN.

Decision D-32 en docs/decisiones.md; runbook 9 en docs/devops/COMANDOS.md.
</commit_message>
<xml_diff>
--- a/docs/informe/exposicion-gs08-2026-10-13.pptx
+++ b/docs/informe/exposicion-gs08-2026-10-13.pptx
@@ -13,8 +13,10 @@
     <p:sldId id="261" r:id="rId13"/>
     <p:sldId id="266" r:id="rId18"/>
     <p:sldId id="262" r:id="rId14"/>
+    <p:sldId id="267" r:id="rId19"/>
     <p:sldId id="263" r:id="rId15"/>
     <p:sldId id="264" r:id="rId16"/>
+    <p:sldId id="268" r:id="rId20"/>
     <p:sldId id="265" r:id="rId17"/>
   </p:sldIdLst>
   <p:sldSz cx="12191695" cy="6858000" type="screen4x3"/>
@@ -4351,21 +4353,21 @@
             <a:pPr/>
             <a:r>
               <a:rPr sz="1500"/>
-              <a:t>22 criterios verificados con corrida real · 4 incumplidos por los dos 500 · 2 en arreglo · 6 pendientes de interfaz · 5 bloqueados con motivo.</a:t>
+              <a:t>Los 39 criterios del alcance quedan cubiertos con corrida real: recorrido E2E de 39 OK y las pruebas automatizadas (121 del backend con 90 % de cobertura y 25 del SPA).</a:t>
             </a:r>
           </a:p>
           <a:p>
             <a:pPr/>
             <a:r>
               <a:rPr sz="1500"/>
-              <a:t>9 bugs documentados con pasos, esperado, obtenido y evidencia — y 4 bugs encontrados en el propio script de pruebas.</a:t>
+              <a:t>9 bugs del sistema y 4 del propio script de pruebas, todos cerrados con evidencia: un bug no se cierra por decisión, se cierra con la corrida verde pegada.</a:t>
             </a:r>
           </a:p>
           <a:p>
             <a:pPr/>
             <a:r>
               <a:rPr sz="1500"/>
-              <a:t>Hallazgos que valieron la pena: un verificador que fallaba en entorno limpio, criterios con datos inexistentes y un /metrics que devolvía el SPA.</a:t>
+              <a:t>Verificar en el navegador encontró 3 cosas que las pruebas simuladas no ven (D-31): un fallo transitorio de Mongo o Redis apagaba la bitácora para siempre, la pantalla de Auditoría decía «apagada» cuando la consulta había fallado, y una sesión vencida dejaba un estado falso.</a:t>
             </a:r>
           </a:p>
           <a:p>
@@ -4434,28 +4436,262 @@
             <a:pPr/>
             <a:r>
               <a:rPr sz="1500"/>
-              <a:t>Sprint 0 cerrado con evidencia: alcance, modelo de datos verificado, infraestructura probada, plan de pruebas y documentación completa.</a:t>
+              <a:t>Sprint 0 a Sprint 4: los cinco cerrados con evidencia (alcance, modelo verificado, API, SPA, capa de rúbrica, producción y documentación).</a:t>
             </a:r>
           </a:p>
           <a:p>
             <a:pPr/>
             <a:r>
               <a:rPr sz="1500"/>
-              <a:t>Sprint 1 en curso (28 endpoints, 22 criterios verdes) y Sprint 3 adelantado: notas y boleta funcionando.</a:t>
+              <a:t>Sprint 1 y 2: API núcleo con contrato probado y el SPA con siete pantallas en React 19; los dos 500 de los POST cerrados.</a:t>
             </a:r>
           </a:p>
           <a:p>
             <a:pPr/>
             <a:r>
               <a:rPr sz="1500"/>
-              <a:t>Bloqueado y dicho de frente: cluster de Kubernetes (A-02), repositorio público y CI, y el SPA (T2.4).</a:t>
+              <a:t>Sprint 3 y 4: notas y boleta con una sola fórmula de promedio, capa de rúbrica completa (MongoDB, Redis, GraphQL, OAuth2 con scopes, logging y accesibilidad) y publicación en producción.</a:t>
             </a:r>
           </a:p>
           <a:p>
             <a:pPr/>
             <a:r>
               <a:rPr sz="1500"/>
-              <a:t>Retrospectiva: probar temprano pagó; cada hallazgo terminó en una decisión o en una tarea con dueño.</a:t>
+              <a:t>Único bloqueo declarado: Kubernetes real sin desplegar (A-02); Express.js queda como decisión abierta (A-04) con plan B de un día.</a:t>
+            </a:r>
+          </a:p>
+        </p:txBody>
+      </p:sp>
+    </p:spTree>
+  </p:cSld>
+  <p:clrMapOvr>
+    <a:masterClrMapping/>
+  </p:clrMapOvr>
+</p:sld>
+</file>
+
+<file path=ppt/slides/slide12.xml><?xml version="1.0" encoding="utf-8"?>
+<p:sld xmlns:a="http://schemas.openxmlformats.org/drawingml/2006/main" xmlns:p="http://schemas.openxmlformats.org/presentationml/2006/main" xmlns:r="http://schemas.openxmlformats.org/officeDocument/2006/relationships">
+  <p:cSld>
+    <p:spTree>
+      <p:nvGrpSpPr>
+        <p:cNvPr id="1" name=""/>
+        <p:cNvGrpSpPr/>
+        <p:nvPr/>
+      </p:nvGrpSpPr>
+      <p:grpSpPr/>
+      <p:sp>
+        <p:nvSpPr>
+          <p:cNvPr id="2" name="Title 1"/>
+          <p:cNvSpPr>
+            <a:spLocks noGrp="1"/>
+          </p:cNvSpPr>
+          <p:nvPr>
+            <p:ph type="title"/>
+          </p:nvPr>
+        </p:nvSpPr>
+        <p:spPr/>
+        <p:txBody>
+          <a:bodyPr/>
+          <a:lstStyle/>
+          <a:p/>
+        </p:txBody>
+      </p:sp>
+      <p:sp>
+        <p:nvSpPr>
+          <p:cNvPr id="3" name="Content Placeholder 2"/>
+          <p:cNvSpPr>
+            <a:spLocks noGrp="1"/>
+          </p:cNvSpPr>
+          <p:nvPr>
+            <p:ph idx="1"/>
+          </p:nvPr>
+        </p:nvSpPr>
+        <p:spPr/>
+        <p:txBody>
+          <a:bodyPr/>
+          <a:lstStyle/>
+          <a:p/>
+        </p:txBody>
+      </p:sp>
+      <p:sp>
+        <p:nvSpPr>
+          <p:cNvPr id="2" name="Title 1"/>
+          <p:cNvSpPr>
+            <a:spLocks noGrp="1"/>
+          </p:cNvSpPr>
+          <p:nvPr>
+            <p:ph type="title"/>
+          </p:nvPr>
+        </p:nvSpPr>
+        <p:spPr/>
+        <p:txBody>
+          <a:bodyPr/>
+          <a:lstStyle/>
+          <a:p>
+            <a:r>
+              <a:t>Capa de rúbrica del API: segunda base, caché, GraphQL y logging</a:t>
+            </a:r>
+          </a:p>
+        </p:txBody>
+      </p:sp>
+      <p:sp>
+        <p:nvSpPr>
+          <p:cNvPr id="3" name="Content Placeholder 2"/>
+          <p:cNvSpPr>
+            <a:spLocks noGrp="1"/>
+          </p:cNvSpPr>
+          <p:nvPr>
+            <p:ph idx="1"/>
+          </p:nvPr>
+        </p:nvSpPr>
+        <p:spPr/>
+        <p:txBody>
+          <a:bodyPr/>
+          <a:lstStyle/>
+          <a:p>
+            <a:pPr/>
+            <a:r>
+              <a:rPr sz="1500"/>
+              <a:t>Segunda base documental (MongoDB 8.0): la bitácora guarda usuario, acción, entidad, resultado y duración de cada escritura, con contraseñas y tokens enmascarados («***»).</a:t>
+            </a:r>
+          </a:p>
+          <a:p>
+            <a:pPr/>
+            <a:r>
+              <a:rPr sz="1500"/>
+              <a:t>Caché distribuida (Redis 8): el panel se arma una vez y se guarda 60 s; medido con 20 000 estudiantes y 20 000 matrículas: 54,2 ms → 13,5 ms (4,0×), y cualquier escritura la invalida sola.</a:t>
+            </a:r>
+          </a:p>
+          <a:p>
+            <a:pPr/>
+            <a:r>
+              <a:rPr sz="1500"/>
+              <a:t>GraphQL en /graphql (Strawberry) con la consulta de boleta, que comparte una sola fórmula de promedio ponderado con el REST.</a:t>
+            </a:r>
+          </a:p>
+          <a:p>
+            <a:pPr/>
+            <a:r>
+              <a:rPr sz="1500"/>
+              <a:t>Logging centralizado: JSON con identificador de petición, usuario, ruta, estado y duración; Grafana lee la serie {servicio="gs08-api"} desde Loki.</a:t>
+            </a:r>
+          </a:p>
+        </p:txBody>
+      </p:sp>
+    </p:spTree>
+  </p:cSld>
+  <p:clrMapOvr>
+    <a:masterClrMapping/>
+  </p:clrMapOvr>
+</p:sld>
+</file>
+
+<file path=ppt/slides/slide13.xml><?xml version="1.0" encoding="utf-8"?>
+<p:sld xmlns:a="http://schemas.openxmlformats.org/drawingml/2006/main" xmlns:p="http://schemas.openxmlformats.org/presentationml/2006/main" xmlns:r="http://schemas.openxmlformats.org/officeDocument/2006/relationships">
+  <p:cSld>
+    <p:spTree>
+      <p:nvGrpSpPr>
+        <p:cNvPr id="1" name=""/>
+        <p:cNvGrpSpPr/>
+        <p:nvPr/>
+      </p:nvGrpSpPr>
+      <p:grpSpPr/>
+      <p:sp>
+        <p:nvSpPr>
+          <p:cNvPr id="2" name="Title 1"/>
+          <p:cNvSpPr>
+            <a:spLocks noGrp="1"/>
+          </p:cNvSpPr>
+          <p:nvPr>
+            <p:ph type="title"/>
+          </p:nvPr>
+        </p:nvSpPr>
+        <p:spPr/>
+        <p:txBody>
+          <a:bodyPr/>
+          <a:lstStyle/>
+          <a:p/>
+        </p:txBody>
+      </p:sp>
+      <p:sp>
+        <p:nvSpPr>
+          <p:cNvPr id="3" name="Content Placeholder 2"/>
+          <p:cNvSpPr>
+            <a:spLocks noGrp="1"/>
+          </p:cNvSpPr>
+          <p:nvPr>
+            <p:ph idx="1"/>
+          </p:nvPr>
+        </p:nvSpPr>
+        <p:spPr/>
+        <p:txBody>
+          <a:bodyPr/>
+          <a:lstStyle/>
+          <a:p/>
+        </p:txBody>
+      </p:sp>
+      <p:sp>
+        <p:nvSpPr>
+          <p:cNvPr id="2" name="Title 1"/>
+          <p:cNvSpPr>
+            <a:spLocks noGrp="1"/>
+          </p:cNvSpPr>
+          <p:nvPr>
+            <p:ph type="title"/>
+          </p:nvPr>
+        </p:nvSpPr>
+        <p:spPr/>
+        <p:txBody>
+          <a:bodyPr/>
+          <a:lstStyle/>
+          <a:p>
+            <a:r>
+              <a:t>Seguridad, accesibilidad y producción</a:t>
+            </a:r>
+          </a:p>
+        </p:txBody>
+      </p:sp>
+      <p:sp>
+        <p:nvSpPr>
+          <p:cNvPr id="3" name="Content Placeholder 2"/>
+          <p:cNvSpPr>
+            <a:spLocks noGrp="1"/>
+          </p:cNvSpPr>
+          <p:nvPr>
+            <p:ph idx="1"/>
+          </p:nvPr>
+        </p:nvSpPr>
+        <p:spPr/>
+        <p:txBody>
+          <a:bodyPr/>
+          <a:lstStyle/>
+          <a:p>
+            <a:pPr/>
+            <a:r>
+              <a:rPr sz="1500"/>
+              <a:t>OAuth2 con scopes: POST /api/v1/auth/token (password grant, RFC 6749 §4.3) con 16 scopes repartidos por rol; si al token le falta el permiso responde 403 insufficient_scope con WWW-Authenticate.</a:t>
+            </a:r>
+          </a:p>
+          <a:p>
+            <a:pPr/>
+            <a:r>
+              <a:rPr sz="1500"/>
+              <a:t>Accesibilidad WCAG 2.1 AA medida: foco atrapado en los diálogos, «Saltar al contenido», aria-current en el menú, caption y scope en las tablas; 14/14 pares de contraste cumplen AA y el anillo de foco 5.93:1.</a:t>
+            </a:r>
+          </a:p>
+          <a:p>
+            <a:pPr/>
+            <a:r>
+              <a:rPr sz="1500"/>
+              <a:t>25 pruebas del SPA con axe-core y 121 del backend con 90 % de cobertura; los cinco jobs del CI en verde en cada push.</a:t>
+            </a:r>
+          </a:p>
+          <a:p>
+            <a:pPr/>
+            <a:r>
+              <a:rPr sz="1500" b="1"/>
+              <a:t>En producción (https://gs08-matriculas.mlarca.com): deploy verificado el 14/10 — SPA React sirviendo, login con 16 scopes, bitácora activa y 20/20 llamadas al health sin fallos.</a:t>
             </a:r>
           </a:p>
         </p:txBody>
@@ -4761,13 +4997,13 @@
           <a:p>
             <a:r>
               <a:rPr sz="1500"/>
-              <a:t>30 operaciones en 16 rutas, publicadas en su propio OpenAPI (versión 0.1.0): salud, autenticación, panel, estudiantes, cursos, matrículas, usuarios, notas y boleta.</a:t>
+              <a:t>20 rutas y 35 operaciones en su propio OpenAPI (v0.3.0), más GraphQL en /graphql: salud, autenticación, panel, estudiantes, cursos, matrículas, usuarios, notas, boleta, auditoría y boleta archivada.</a:t>
             </a:r>
           </a:p>
           <a:p>
             <a:r>
               <a:rPr sz="1500"/>
-              <a:t>Códigos como contrato: 200/201/204 lo correcto · 401 sin sesión · 403 por rol · 404 · 409 duplicado · 422 dato inválido.</a:t>
+              <a:t>Códigos como contrato: 200/201/204 lo correcto · 400 invalid_grant o invalid_scope · 401 sin sesión · 403 por rol o por scope · 404 · 409 duplicado · 422 dato inválido.</a:t>
             </a:r>
           </a:p>
           <a:p>
@@ -4779,7 +5015,7 @@
           <a:p>
             <a:r>
               <a:rPr sz="1500"/>
-              <a:t>Las 30 operaciones están consumidas desde el SPA y verificadas contra la API real.</a:t>
+              <a:t>Todas las operaciones se consumen desde el SPA y se verificaron contra la API real; los dos 500 de los POST de matrículas y usuarios quedaron cerrados.</a:t>
             </a:r>
           </a:p>
         </p:txBody>
@@ -4840,7 +5076,7 @@
           <a:p>
             <a:r>
               <a:rPr sz="1500"/>
-              <a:t>Entrar → panel con los 4 indicadores → buscar «huaman» y encontrar «Huamán» → registrar estudiante → matricular → 3 notas → ver la boleta → cursos y usuarios.</a:t>
+              <a:t>Entrar → panel con los 4 indicadores → buscar «huaman» y encontrar «Huamán» → registrar estudiante → matricular → 3 notas → ver la boleta → cursos, usuarios y la pantalla de Auditoría (bitácora y boleta archivada).</a:t>
             </a:r>
           </a:p>
           <a:p>
@@ -4999,7 +5235,7 @@
             <a:pPr/>
             <a:r>
               <a:rPr sz="1500"/>
-              <a:t>6 contenedores con un solo comando: web (nginx 8080), dos instancias del API, PostgreSQL, Prometheus y Grafana.</a:t>
+              <a:t>8 servicios con un solo comando: web (nginx: 80 en producción, 8080 en local), dos instancias del API, PostgreSQL, MongoDB, Redis, Prometheus y Grafana.</a:t>
             </a:r>
           </a:p>
           <a:p>
@@ -5013,14 +5249,14 @@
             <a:pPr/>
             <a:r>
               <a:rPr sz="1500"/>
-              <a:t>CI en cada pull request: infra + backend (ruff y pytest, cobertura mínima 60 %) + frontend + imágenes con smoke y escaneo.</a:t>
+              <a:t>CI en cada push a main: infraestructura + backend (ruff y 121 pruebas, 90 % de cobertura) + frontend (25 pruebas, eslint y build) + imágenes con humo; los cinco jobs están en verde.</a:t>
             </a:r>
           </a:p>
           <a:p>
             <a:pPr/>
             <a:r>
               <a:rPr sz="1500"/>
-              <a:t>CD: publica en GHCR con SBOM y provenance; el despliegue a Kubernetes queda guardado tras DEPLOY_ENABLED=true.</a:t>
+              <a:t>CD real: Coolify reconstruye y despliega desde main; el deploy del 14/10 tardó 57 s y quedó verificado (health 200, login con 16 scopes y bitácora activa).</a:t>
             </a:r>
           </a:p>
         </p:txBody>

</xml_diff>

<commit_message>
docs(informe): deck final (13 laminas) con el cierre por sprint y el CD de GitHub Actions
Retoques de la ultima revision: la lamina 13 deja de decir 'entregado,
bloqueado' (los cinco sprints estan cerrados) y la lamina 8 cuenta el CD real
(GitHub Actions pide el despliegue a Coolify y verifica produccion). Se
regeneran el pptx y su PDF.
</commit_message>
<xml_diff>
--- a/docs/informe/exposicion-gs08-2026-10-13.pptx
+++ b/docs/informe/exposicion-gs08-2026-10-13.pptx
@@ -4330,7 +4330,7 @@
           <a:lstStyle/>
           <a:p>
             <a:r>
-              <a:t>Calidad: 39 criterios y lo que apareció probando</a:t>
+              <a:t>Kubernetes local y observabilidad</a:t>
             </a:r>
           </a:p>
         </p:txBody>
@@ -4353,28 +4353,28 @@
             <a:pPr/>
             <a:r>
               <a:rPr sz="1500"/>
-              <a:t>Los 39 criterios del alcance quedan cubiertos con corrida real: recorrido E2E de 39 OK y las pruebas automatizadas (121 del backend con 90 % de cobertura y 25 del SPA).</a:t>
+              <a:t>11 objetos definidos y validados offline con kustomize: Namespace, ConfigMap, PVC, Job de migraciones, Deployments, Services e Ingress.</a:t>
             </a:r>
           </a:p>
           <a:p>
             <a:pPr/>
             <a:r>
               <a:rPr sz="1500"/>
-              <a:t>9 bugs del sistema y 4 del propio script de pruebas, todos cerrados con evidencia: un bug no se cierra por decisión, se cierra con la corrida verde pegada.</a:t>
+              <a:t>En el cluster el esquema lo aplica Alembic con el Job de migraciones, no los scripts de inicialización.</a:t>
             </a:r>
           </a:p>
           <a:p>
             <a:pPr/>
             <a:r>
               <a:rPr sz="1500"/>
-              <a:t>Verificar en el navegador encontró 3 cosas que las pruebas simuladas no ven (D-31): un fallo transitorio de Mongo o Redis apagaba la bitácora para siempre, la pantalla de Auditoría decía «apagada» cuando la consulta había fallado, y una sesión vencida dejaba un estado falso.</a:t>
+              <a:t>Observabilidad corriendo: 3 targets up y un dashboard API RED con 9 paneles con datos, provisionado desde el repositorio.</a:t>
             </a:r>
           </a:p>
           <a:p>
             <a:pPr/>
             <a:r>
               <a:rPr sz="1500" b="1"/>
-              <a:t>Regla de la casa: un bug no se cierra por decisión, se cierra con la corrida verde pegada.</a:t>
+              <a:t>ESTADO REAL: el cluster NO está desplegado en esta máquina — minikube no está instalado y espera aprobación (A-02).</a:t>
             </a:r>
           </a:p>
         </p:txBody>
@@ -4413,7 +4413,7 @@
           <a:lstStyle/>
           <a:p>
             <a:r>
-              <a:t>Sprint 0 → Sprint 4: entregado, bloqueado y retrospectiva</a:t>
+              <a:t>Calidad: 39 criterios y lo que apareció probando</a:t>
             </a:r>
           </a:p>
         </p:txBody>
@@ -4436,28 +4436,28 @@
             <a:pPr/>
             <a:r>
               <a:rPr sz="1500"/>
-              <a:t>Sprint 0 a Sprint 4: los cinco cerrados con evidencia (alcance, modelo verificado, API, SPA, capa de rúbrica, producción y documentación).</a:t>
+              <a:t>Los 39 criterios del alcance quedan cubiertos con corrida real: recorrido E2E de 39 OK y las pruebas automatizadas (121 del backend con 90 % de cobertura y 25 del SPA).</a:t>
             </a:r>
           </a:p>
           <a:p>
             <a:pPr/>
             <a:r>
               <a:rPr sz="1500"/>
-              <a:t>Sprint 1 y 2: API núcleo con contrato probado y el SPA con siete pantallas en React 19; los dos 500 de los POST cerrados.</a:t>
+              <a:t>9 bugs del sistema y 4 del propio script de pruebas, todos cerrados con evidencia: un bug no se cierra por decisión, se cierra con la corrida verde pegada.</a:t>
             </a:r>
           </a:p>
           <a:p>
             <a:pPr/>
             <a:r>
               <a:rPr sz="1500"/>
-              <a:t>Sprint 3 y 4: notas y boleta con una sola fórmula de promedio, capa de rúbrica completa (MongoDB, Redis, GraphQL, OAuth2 con scopes, logging y accesibilidad) y publicación en producción.</a:t>
+              <a:t>Verificar en el navegador encontró 3 cosas que las pruebas simuladas no ven (D-31): un fallo transitorio de Mongo o Redis apagaba la bitácora para siempre, la pantalla de Auditoría decía «apagada» cuando la consulta había fallado, y una sesión vencida dejaba un estado falso.</a:t>
             </a:r>
           </a:p>
           <a:p>
             <a:pPr/>
             <a:r>
-              <a:rPr sz="1500"/>
-              <a:t>Único bloqueo declarado: Kubernetes real sin desplegar (A-02); Express.js queda como decisión abierta (A-04) con plan B de un día.</a:t>
+              <a:rPr sz="1500" b="1"/>
+              <a:t>Regla de la casa: un bug no se cierra por decisión, se cierra con la corrida verde pegada.</a:t>
             </a:r>
           </a:p>
         </p:txBody>
@@ -4530,7 +4530,7 @@
           <a:lstStyle/>
           <a:p>
             <a:r>
-              <a:t>Capa de rúbrica del API: segunda base, caché, GraphQL y logging</a:t>
+              <a:t>Seguridad, accesibilidad y producción</a:t>
             </a:r>
           </a:p>
         </p:txBody>
@@ -4553,28 +4553,28 @@
             <a:pPr/>
             <a:r>
               <a:rPr sz="1500"/>
-              <a:t>Segunda base documental (MongoDB 8.0): la bitácora guarda usuario, acción, entidad, resultado y duración de cada escritura, con contraseñas y tokens enmascarados («***»).</a:t>
+              <a:t>OAuth2 con scopes: POST /api/v1/auth/token (password grant, RFC 6749 §4.3) con 16 scopes repartidos por rol; si al token le falta el permiso responde 403 insufficient_scope con WWW-Authenticate.</a:t>
             </a:r>
           </a:p>
           <a:p>
             <a:pPr/>
             <a:r>
               <a:rPr sz="1500"/>
-              <a:t>Caché distribuida (Redis 8): el panel se arma una vez y se guarda 60 s; medido con 20 000 estudiantes y 20 000 matrículas: 54,2 ms → 13,5 ms (4,0×), y cualquier escritura la invalida sola.</a:t>
+              <a:t>Accesibilidad WCAG 2.1 AA medida: foco atrapado en los diálogos, «Saltar al contenido», aria-current en el menú, caption y scope en las tablas; 14/14 pares de contraste cumplen AA y el anillo de foco 5.93:1.</a:t>
             </a:r>
           </a:p>
           <a:p>
             <a:pPr/>
             <a:r>
               <a:rPr sz="1500"/>
-              <a:t>GraphQL en /graphql (Strawberry) con la consulta de boleta, que comparte una sola fórmula de promedio ponderado con el REST.</a:t>
+              <a:t>25 pruebas del SPA con axe-core y 121 del backend con 90 % de cobertura; los cinco jobs del CI en verde en cada push.</a:t>
             </a:r>
           </a:p>
           <a:p>
             <a:pPr/>
             <a:r>
-              <a:rPr sz="1500"/>
-              <a:t>Logging centralizado: JSON con identificador de petición, usuario, ruta, estado y duración; Grafana lee la serie {servicio="gs08-api"} desde Loki.</a:t>
+              <a:rPr sz="1500" b="1"/>
+              <a:t>En producción (https://gs08-matriculas.mlarca.com): deploy verificado el 14/10 — SPA React sirviendo, login con 16 scopes, bitácora activa y 20/20 llamadas al health sin fallos.</a:t>
             </a:r>
           </a:p>
         </p:txBody>
@@ -4611,7 +4611,11 @@
         <p:txBody>
           <a:bodyPr/>
           <a:lstStyle/>
-          <a:p/>
+          <a:p>
+            <a:r>
+              <a:t>Sprint 0 → Sprint 4: los cinco cerrados y la retrospectiva</a:t>
+            </a:r>
+          </a:p>
         </p:txBody>
       </p:sp>
       <p:sp>
@@ -4628,70 +4632,32 @@
         <p:txBody>
           <a:bodyPr/>
           <a:lstStyle/>
-          <a:p/>
-        </p:txBody>
-      </p:sp>
-      <p:sp>
-        <p:nvSpPr>
-          <p:cNvPr id="2" name="Title 1"/>
-          <p:cNvSpPr>
-            <a:spLocks noGrp="1"/>
-          </p:cNvSpPr>
-          <p:nvPr>
-            <p:ph type="title"/>
-          </p:nvPr>
-        </p:nvSpPr>
-        <p:spPr/>
-        <p:txBody>
-          <a:bodyPr/>
-          <a:lstStyle/>
-          <a:p>
-            <a:r>
-              <a:t>Seguridad, accesibilidad y producción</a:t>
-            </a:r>
-          </a:p>
-        </p:txBody>
-      </p:sp>
-      <p:sp>
-        <p:nvSpPr>
-          <p:cNvPr id="3" name="Content Placeholder 2"/>
-          <p:cNvSpPr>
-            <a:spLocks noGrp="1"/>
-          </p:cNvSpPr>
-          <p:nvPr>
-            <p:ph idx="1"/>
-          </p:nvPr>
-        </p:nvSpPr>
-        <p:spPr/>
-        <p:txBody>
-          <a:bodyPr/>
-          <a:lstStyle/>
           <a:p>
             <a:pPr/>
             <a:r>
               <a:rPr sz="1500"/>
-              <a:t>OAuth2 con scopes: POST /api/v1/auth/token (password grant, RFC 6749 §4.3) con 16 scopes repartidos por rol; si al token le falta el permiso responde 403 insufficient_scope con WWW-Authenticate.</a:t>
+              <a:t>Sprint 0 a Sprint 4: los cinco cerrados con evidencia (alcance, modelo verificado, API, SPA, capa de rúbrica, producción y documentación).</a:t>
             </a:r>
           </a:p>
           <a:p>
             <a:pPr/>
             <a:r>
               <a:rPr sz="1500"/>
-              <a:t>Accesibilidad WCAG 2.1 AA medida: foco atrapado en los diálogos, «Saltar al contenido», aria-current en el menú, caption y scope en las tablas; 14/14 pares de contraste cumplen AA y el anillo de foco 5.93:1.</a:t>
+              <a:t>Sprint 1 y 2: API núcleo con contrato probado y el SPA con siete pantallas en React 19; los dos 500 de los POST cerrados.</a:t>
             </a:r>
           </a:p>
           <a:p>
             <a:pPr/>
             <a:r>
               <a:rPr sz="1500"/>
-              <a:t>25 pruebas del SPA con axe-core y 121 del backend con 90 % de cobertura; los cinco jobs del CI en verde en cada push.</a:t>
+              <a:t>Sprint 3 y 4: notas y boleta con una sola fórmula de promedio, capa de rúbrica completa (MongoDB, Redis, GraphQL, OAuth2 con scopes, logging y accesibilidad) y publicación en producción.</a:t>
             </a:r>
           </a:p>
           <a:p>
             <a:pPr/>
             <a:r>
-              <a:rPr sz="1500" b="1"/>
-              <a:t>En producción (https://gs08-matriculas.mlarca.com): deploy verificado el 14/10 — SPA React sirviendo, login con 16 scopes, bitácora activa y 20/20 llamadas al health sin fallos.</a:t>
+              <a:rPr sz="1500"/>
+              <a:t>Único bloqueo declarado: Kubernetes real sin desplegar (A-02); Express.js queda como decisión abierta (A-04) con plan B de un día.</a:t>
             </a:r>
           </a:p>
         </p:txBody>
@@ -5256,7 +5222,7 @@
             <a:pPr/>
             <a:r>
               <a:rPr sz="1500"/>
-              <a:t>CD real: Coolify reconstruye y despliega desde main; el deploy del 14/10 tardó 57 s y quedó verificado (health 200, login con 16 scopes y bitácora activa).</a:t>
+              <a:t>CD en GitHub Actions: al terminar el CI en verde sobre main pide el despliegue a Coolify y verifica producción</a:t>
             </a:r>
           </a:p>
         </p:txBody>
@@ -5293,11 +5259,7 @@
         <p:txBody>
           <a:bodyPr/>
           <a:lstStyle/>
-          <a:p>
-            <a:r>
-              <a:t>Kubernetes local y observabilidad</a:t>
-            </a:r>
-          </a:p>
+          <a:p/>
         </p:txBody>
       </p:sp>
       <p:sp>
@@ -5314,32 +5276,70 @@
         <p:txBody>
           <a:bodyPr/>
           <a:lstStyle/>
+          <a:p/>
+        </p:txBody>
+      </p:sp>
+      <p:sp>
+        <p:nvSpPr>
+          <p:cNvPr id="2" name="Title 1"/>
+          <p:cNvSpPr>
+            <a:spLocks noGrp="1"/>
+          </p:cNvSpPr>
+          <p:nvPr>
+            <p:ph type="title"/>
+          </p:nvPr>
+        </p:nvSpPr>
+        <p:spPr/>
+        <p:txBody>
+          <a:bodyPr/>
+          <a:lstStyle/>
+          <a:p>
+            <a:r>
+              <a:t>Capa de rúbrica del API: segunda base, caché, GraphQL y logging</a:t>
+            </a:r>
+          </a:p>
+        </p:txBody>
+      </p:sp>
+      <p:sp>
+        <p:nvSpPr>
+          <p:cNvPr id="3" name="Content Placeholder 2"/>
+          <p:cNvSpPr>
+            <a:spLocks noGrp="1"/>
+          </p:cNvSpPr>
+          <p:nvPr>
+            <p:ph idx="1"/>
+          </p:nvPr>
+        </p:nvSpPr>
+        <p:spPr/>
+        <p:txBody>
+          <a:bodyPr/>
+          <a:lstStyle/>
           <a:p>
             <a:pPr/>
             <a:r>
               <a:rPr sz="1500"/>
-              <a:t>11 objetos definidos y validados offline con kustomize: Namespace, ConfigMap, PVC, Job de migraciones, Deployments, Services e Ingress.</a:t>
+              <a:t>Segunda base documental (MongoDB 8.0): la bitácora guarda usuario, acción, entidad, resultado y duración de cada escritura, con contraseñas y tokens enmascarados («***»).</a:t>
             </a:r>
           </a:p>
           <a:p>
             <a:pPr/>
             <a:r>
               <a:rPr sz="1500"/>
-              <a:t>En el cluster el esquema lo aplica Alembic con el Job de migraciones, no los scripts de inicialización.</a:t>
+              <a:t>Caché distribuida (Redis 8): el panel se arma una vez y se guarda 60 s; medido con 20 000 estudiantes y 20 000 matrículas: 54,2 ms → 13,5 ms (4,0×), y cualquier escritura la invalida sola.</a:t>
             </a:r>
           </a:p>
           <a:p>
             <a:pPr/>
             <a:r>
               <a:rPr sz="1500"/>
-              <a:t>Observabilidad corriendo: 3 targets up y un dashboard API RED con 9 paneles con datos, provisionado desde el repositorio.</a:t>
+              <a:t>GraphQL en /graphql (Strawberry) con la consulta de boleta, que comparte una sola fórmula de promedio ponderado con el REST.</a:t>
             </a:r>
           </a:p>
           <a:p>
             <a:pPr/>
             <a:r>
-              <a:rPr sz="1500" b="1"/>
-              <a:t>ESTADO REAL: el cluster NO está desplegado en esta máquina — minikube no está instalado y espera aprobación (A-02).</a:t>
+              <a:rPr sz="1500"/>
+              <a:t>Logging centralizado: JSON con identificador de petición, usuario, ruta, estado y duración; Grafana lee la serie {servicio="gs08-api"} desde Loki.</a:t>
             </a:r>
           </a:p>
         </p:txBody>

</xml_diff>

<commit_message>
fix(entrega): el grupo es de dos integrantes (Arteaga Rullier y Inocencio Gargate)
Se quita a Jorge Luis Diaz Cardenas de la portada y las firmas del informe, de la
caratula del deck, del anexo, del LEEME y del reparto de tareas del acta, la
retrospectiva y el backlog. Roberto asume tambien el backend. Se agrega la
decision D-33 que deja constancia del cambio y se actualizan fecha y version
(v3, 19/10/2026) del informe.
</commit_message>
<xml_diff>
--- a/docs/informe/exposicion-gs08-2026-10-13.pptx
+++ b/docs/informe/exposicion-gs08-2026-10-13.pptx
@@ -4270,21 +4270,14 @@
             <a:pPr/>
             <a:r>
               <a:rPr sz="1600"/>
-              <a:t>Arteaga Rullier, Roberto — Scrum Master + DevOps</a:t>
+              <a:t>Arteaga Rullier, Roberto — Scrum Master, DevOps y Backend</a:t>
             </a:r>
           </a:p>
           <a:p>
             <a:pPr/>
             <a:r>
               <a:rPr sz="1600"/>
-              <a:t>Díaz Cárdenas, Jorge Luis — Backend</a:t>
-            </a:r>
-          </a:p>
-          <a:p>
-            <a:pPr/>
-            <a:r>
-              <a:rPr sz="1600"/>
-              <a:t>Inocencio Gargate, Dalcir — Frontend + Documentador</a:t>
+              <a:t>Inocencio Gargate, Dalcir — Frontend y Documentación</a:t>
             </a:r>
           </a:p>
           <a:p>

</xml_diff>